<commit_message>
Add standard Reflection element to DMP2 kits 014-018; 017 Videos page; QA.md moved to QA-v2.md (needs re-QA)
Co-Authored-By: Claude Sonnet 5.5 <noreply@anthropic.com>
Claude-Session: https://claude.ai/code/session_01Bk9BZT9NJebJJy1NsCqBgC
</commit_message>
<xml_diff>
--- a/tpt/014-dmp2-billboard-top-10/billboard-top-10-intro-deck.pptx
+++ b/tpt/014-dmp2-billboard-top-10/billboard-top-10-intro-deck.pptx
@@ -1078,7 +1078,7 @@
           <a:lstStyle/>
           <a:p>
             <a:r>
-              <a:t>Close with what my teacher notes say this project does: it teaches students to listen analytically rather than passively. They matched a real hit’s tempo, form and instrumentation with precision, and still made creative production choices of their own. That is how producers learn.</a:t>
+              <a:t>Close with what my teacher notes say this project does: it teaches students to listen analytically rather than passively. They matched a real hit’s tempo, form and instrumentation with precision, and still made creative production choices of their own. That is how producers learn. Reflection: point students to the Reflection page. A reflection is a written or oral conversation about how they did on the project and what they would do differently next time; they choose to write it or to talk it through with you.</a:t>
             </a:r>
           </a:p>
         </p:txBody>
@@ -10973,6 +10973,120 @@
           </a:prstGeom>
         </p:spPr>
       </p:pic>
+      <p:sp>
+        <p:nvSpPr>
+          <p:cNvPr id="19" name="Rounded Rectangle 18"/>
+          <p:cNvSpPr/>
+          <p:nvPr/>
+        </p:nvSpPr>
+        <p:spPr>
+          <a:xfrm>
+            <a:off x="548640" y="5349240"/>
+            <a:ext cx="5852160" cy="960120"/>
+          </a:xfrm>
+          <a:prstGeom prst="roundRect">
+            <a:avLst/>
+          </a:prstGeom>
+          <a:solidFill>
+            <a:srgbClr val="B0127A"/>
+          </a:solidFill>
+          <a:ln>
+            <a:noFill/>
+          </a:ln>
+          <a:effectLst/>
+        </p:spPr>
+        <p:style>
+          <a:lnRef idx="1">
+            <a:schemeClr val="accent1"/>
+          </a:lnRef>
+          <a:fillRef idx="3">
+            <a:schemeClr val="accent1"/>
+          </a:fillRef>
+          <a:effectRef idx="2">
+            <a:schemeClr val="accent1"/>
+          </a:effectRef>
+          <a:fontRef idx="minor">
+            <a:schemeClr val="lt1"/>
+          </a:fontRef>
+        </p:style>
+        <p:txBody>
+          <a:bodyPr rtlCol="0" anchor="ctr"/>
+          <a:lstStyle/>
+          <a:p>
+            <a:pPr algn="ctr"/>
+          </a:p>
+        </p:txBody>
+      </p:sp>
+      <p:sp>
+        <p:nvSpPr>
+          <p:cNvPr id="20" name="TextBox 19"/>
+          <p:cNvSpPr txBox="1"/>
+          <p:nvPr/>
+        </p:nvSpPr>
+        <p:spPr>
+          <a:xfrm>
+            <a:off x="731520" y="5394960"/>
+            <a:ext cx="5486400" cy="365760"/>
+          </a:xfrm>
+          <a:prstGeom prst="rect">
+            <a:avLst/>
+          </a:prstGeom>
+          <a:noFill/>
+        </p:spPr>
+        <p:txBody>
+          <a:bodyPr wrap="square" anchor="t" lIns="36576" rIns="36576" tIns="18288" bIns="18288">
+            <a:spAutoFit/>
+          </a:bodyPr>
+          <a:lstStyle/>
+          <a:p>
+            <a:pPr algn="l"/>
+            <a:r>
+              <a:rPr sz="2000" b="1">
+                <a:solidFill>
+                  <a:srgbClr val="FFFFFF"/>
+                </a:solidFill>
+                <a:latin typeface="Oswald"/>
+              </a:rPr>
+              <a:t>REFLECTION · PAGE 20</a:t>
+            </a:r>
+          </a:p>
+        </p:txBody>
+      </p:sp>
+      <p:sp>
+        <p:nvSpPr>
+          <p:cNvPr id="21" name="TextBox 20"/>
+          <p:cNvSpPr txBox="1"/>
+          <p:nvPr/>
+        </p:nvSpPr>
+        <p:spPr>
+          <a:xfrm>
+            <a:off x="731520" y="5760720"/>
+            <a:ext cx="5486400" cy="502920"/>
+          </a:xfrm>
+          <a:prstGeom prst="rect">
+            <a:avLst/>
+          </a:prstGeom>
+          <a:noFill/>
+        </p:spPr>
+        <p:txBody>
+          <a:bodyPr wrap="square" anchor="t" lIns="36576" rIns="36576" tIns="18288" bIns="18288">
+            <a:spAutoFit/>
+          </a:bodyPr>
+          <a:lstStyle/>
+          <a:p>
+            <a:pPr algn="l"/>
+            <a:r>
+              <a:rPr sz="1500" b="0">
+                <a:solidFill>
+                  <a:srgbClr val="FFFFFF"/>
+                </a:solidFill>
+                <a:latin typeface="Source Sans 3"/>
+              </a:rPr>
+              <a:t>Write it or talk it through: what went well, what was hard, what you would change.</a:t>
+            </a:r>
+          </a:p>
+        </p:txBody>
+      </p:sp>
     </p:spTree>
   </p:cSld>
   <p:clrMapOvr>

</xml_diff>